<commit_message>
Chỉnh sửa file PPTX
</commit_message>
<xml_diff>
--- a/PPTX/Ứng Dụng Chat.pptx
+++ b/PPTX/Ứng Dụng Chat.pptx
@@ -3105,7 +3105,7 @@
               <a:t>ủ </a:t>
             </a:r>
             <a:r>
-              <a:rPr lang="" altLang="en-US"/>
+              <a:rPr lang="en-US" altLang="en-US"/>
               <a:t>Đ</a:t>
             </a:r>
             <a:r>
@@ -3133,7 +3133,15 @@
         <p:txBody>
           <a:bodyPr/>
           <a:p>
-            <a:endParaRPr lang="en-US"/>
+            <a:r>
+              <a:rPr lang="en-US"/>
+              <a:t>N</a:t>
+            </a:r>
+            <a:r>
+              <a:rPr lang="en-US" altLang="en-US"/>
+              <a:t>ội DUng Chính</a:t>
+            </a:r>
+            <a:endParaRPr lang="en-US" altLang="en-US"/>
           </a:p>
         </p:txBody>
       </p:sp>

</xml_diff>